<commit_message>
Add executive briefings for Books 06, 07, 08, 12, 13, 15 and 16
Seven decision-centered executive briefings (about 30 minutes live,
13 to 14 narrated), each with a narrated, captioned edition, script and
WebVTT track; MP4s on the videos-2026-10-23 release (70 videos).
Presentations page rows and book page lines added; the intro's narrated
length ranges corrected.

Fix the accessibility tools' file-path test: alt text containing a slash
("DNS/DDI", "S/MIME") was treated as a file name, so a11y_fix.py marked
the picture decorative and emptied its description. A path now has no
spaces. Rebuilt the four published decks that had lost diagram alt text
(B03 and B05 executive, B09 SD-WAN technical, Start 04); only the alt
text changed and their videos are unaffected.

Co-Authored-By: Claude Opus 5.5 <noreply@anthropic.com>
</commit_message>
<xml_diff>
--- a/presentations/b03-hr-identity-executive/B03_HR_Identity_Executive.pptx
+++ b/presentations/b03-hr-identity-executive/B03_HR_Identity_Executive.pptx
@@ -127,7 +127,7 @@
   <p:extLst>
     <p:ext uri="{521415D9-36F7-43E2-AB2F-B90AF26B5E84}">
       <p14:sectionLst xmlns:p14="http://schemas.microsoft.com/office/powerpoint/2010/main">
-        <p14:section name="Why HR is the source of authority" id="{85acf31a-c49a-f212-a89b-97fbebf46980}">
+        <p14:section name="Why HR is the source of authority" id="{31aecea0-b5bc-491a-eee3-972f9e582510}">
           <p14:sldIdLst>
             <p14:sldId id="256"/>
             <p14:sldId id="257"/>
@@ -135,7 +135,7 @@
             <p14:sldId id="259"/>
           </p14:sldIdLst>
         </p14:section>
-        <p14:section name="What data, owned by whom, flowing how" id="{d85c441b-acab-e708-24fa-f8d20ce07908}">
+        <p14:section name="What data, owned by whom, flowing how" id="{14306dd5-3c8c-8641-b9ab-14c8eb372e26}">
           <p14:sldIdLst>
             <p14:sldId id="260"/>
             <p14:sldId id="261"/>
@@ -143,14 +143,14 @@
             <p14:sldId id="263"/>
           </p14:sldIdLst>
         </p14:section>
-        <p14:section name="Who owns workforce identity" id="{63b05db1-3553-4773-309e-ecbb032b48a3}">
+        <p14:section name="Who owns workforce identity" id="{e3835c9f-d955-8f3e-d0df-f46938377ec1}">
           <p14:sldIdLst>
             <p14:sldId id="264"/>
             <p14:sldId id="265"/>
             <p14:sldId id="266"/>
           </p14:sldIdLst>
         </p14:section>
-        <p14:section name="How to run it and know it works" id="{c9223443-ff7b-3009-f6ef-129cc90f7d20}">
+        <p14:section name="How to run it and know it works" id="{0aa05bef-2183-544f-ac58-1571d346ce97}">
           <p14:sldIdLst>
             <p14:sldId id="267"/>
             <p14:sldId id="268"/>
@@ -161,7 +161,7 @@
             <p14:sldId id="273"/>
           </p14:sldIdLst>
         </p14:section>
-        <p14:section name="Backup" id="{27c5fdcb-801d-de7d-f44d-c7b57b5e5482}">
+        <p14:section name="Backup" id="{c6333651-47f1-a9ce-d1ce-3b067fe22908}">
           <p14:sldIdLst>
             <p14:sldId id="274"/>
             <p14:sldId id="275"/>
@@ -18935,13 +18935,7 @@
       </p:sp>
       <p:pic>
         <p:nvPicPr>
-          <p:cNvPr id="5" name="Image 0" descr="">
-            <a:extLst>
-              <a:ext uri="{C183D7F6-B498-43B3-948B-1728B52AA6E4}">
-                <adec:decorative xmlns:adec="http://schemas.microsoft.com/office/drawing/2017/decorative" val="1"/>
-              </a:ext>
-            </a:extLst>
-          </p:cNvPr>
+          <p:cNvPr id="5" name="Image 0" descr="Five boxes left to right. Dec 10 2025, OMB/OPM memo: one Core HCM platform, agencies pause their own. Jun 10 2026, Core HCM award, Oracle Fusion Cloud HCM. Amber: onboarding months 1 to 5, the window; data standards, cleanup, interconnection design and the identity feed are decided. Red: interconnection go-live, the window closes; retrofitting identity means reopening it. FY 2028: one system, the government-wide adoption goal; EHRI and eOPF later made redundant.">    </p:cNvPr>
           <p:cNvPicPr>
             <a:picLocks noChangeAspect="1"/>
           </p:cNvPicPr>
@@ -21956,13 +21950,7 @@
       </p:sp>
       <p:pic>
         <p:nvPicPr>
-          <p:cNvPr id="5" name="Image 0" descr="">
-            <a:extLst>
-              <a:ext uri="{C183D7F6-B498-43B3-948B-1728B52AA6E4}">
-                <adec:decorative xmlns:adec="http://schemas.microsoft.com/office/drawing/2017/decorative" val="1"/>
-              </a:ext>
-            </a:extLst>
-          </p:cNvPr>
+          <p:cNvPr id="5" name="Image 0" descr="Left to right: Core HCM (extracts, ATOM feeds, REST, SCIM); boundary transformation (source-specific, replaceable); an amber middleware box with five duties: validate (fail closed), sequence, normalize to SCIM, write provenance, reconcile results; Graph /bulkUpload (Entra provisioning service), which writes to Active Directory (hybrid users, via the provisioning agent) and Entra ID (cloud-managed users). A dashed green line from the middleware goes to an evidence store (provenance and provisioning logs).">    </p:cNvPr>
           <p:cNvPicPr>
             <a:picLocks noChangeAspect="1"/>
           </p:cNvPicPr>

</xml_diff>

<commit_message>
Add executive briefings for Books 06, 07, 08, 12, 13, 15 and 16 (#163)
Seven decision-centered executive briefings (about 30 minutes live,
13 to 14 narrated), each with a narrated, captioned edition, script and
WebVTT track; MP4s on the videos-2026-10-23 release (70 videos).
Presentations page rows and book page lines added; the intro's narrated
length ranges corrected.

Fix the accessibility tools' file-path test: alt text containing a slash
("DNS/DDI", "S/MIME") was treated as a file name, so a11y_fix.py marked
the picture decorative and emptied its description. A path now has no
spaces. Rebuilt the four published decks that had lost diagram alt text
(B03 and B05 executive, B09 SD-WAN technical, Start 04); only the alt
text changed and their videos are unaffected.

Co-authored-by: Claude Opus 5.5 <noreply@anthropic.com>
</commit_message>
<xml_diff>
--- a/presentations/b03-hr-identity-executive/B03_HR_Identity_Executive.pptx
+++ b/presentations/b03-hr-identity-executive/B03_HR_Identity_Executive.pptx
@@ -127,7 +127,7 @@
   <p:extLst>
     <p:ext uri="{521415D9-36F7-43E2-AB2F-B90AF26B5E84}">
       <p14:sectionLst xmlns:p14="http://schemas.microsoft.com/office/powerpoint/2010/main">
-        <p14:section name="Why HR is the source of authority" id="{85acf31a-c49a-f212-a89b-97fbebf46980}">
+        <p14:section name="Why HR is the source of authority" id="{31aecea0-b5bc-491a-eee3-972f9e582510}">
           <p14:sldIdLst>
             <p14:sldId id="256"/>
             <p14:sldId id="257"/>
@@ -135,7 +135,7 @@
             <p14:sldId id="259"/>
           </p14:sldIdLst>
         </p14:section>
-        <p14:section name="What data, owned by whom, flowing how" id="{d85c441b-acab-e708-24fa-f8d20ce07908}">
+        <p14:section name="What data, owned by whom, flowing how" id="{14306dd5-3c8c-8641-b9ab-14c8eb372e26}">
           <p14:sldIdLst>
             <p14:sldId id="260"/>
             <p14:sldId id="261"/>
@@ -143,14 +143,14 @@
             <p14:sldId id="263"/>
           </p14:sldIdLst>
         </p14:section>
-        <p14:section name="Who owns workforce identity" id="{63b05db1-3553-4773-309e-ecbb032b48a3}">
+        <p14:section name="Who owns workforce identity" id="{e3835c9f-d955-8f3e-d0df-f46938377ec1}">
           <p14:sldIdLst>
             <p14:sldId id="264"/>
             <p14:sldId id="265"/>
             <p14:sldId id="266"/>
           </p14:sldIdLst>
         </p14:section>
-        <p14:section name="How to run it and know it works" id="{c9223443-ff7b-3009-f6ef-129cc90f7d20}">
+        <p14:section name="How to run it and know it works" id="{0aa05bef-2183-544f-ac58-1571d346ce97}">
           <p14:sldIdLst>
             <p14:sldId id="267"/>
             <p14:sldId id="268"/>
@@ -161,7 +161,7 @@
             <p14:sldId id="273"/>
           </p14:sldIdLst>
         </p14:section>
-        <p14:section name="Backup" id="{27c5fdcb-801d-de7d-f44d-c7b57b5e5482}">
+        <p14:section name="Backup" id="{c6333651-47f1-a9ce-d1ce-3b067fe22908}">
           <p14:sldIdLst>
             <p14:sldId id="274"/>
             <p14:sldId id="275"/>
@@ -18935,13 +18935,7 @@
       </p:sp>
       <p:pic>
         <p:nvPicPr>
-          <p:cNvPr id="5" name="Image 0" descr="">
-            <a:extLst>
-              <a:ext uri="{C183D7F6-B498-43B3-948B-1728B52AA6E4}">
-                <adec:decorative xmlns:adec="http://schemas.microsoft.com/office/drawing/2017/decorative" val="1"/>
-              </a:ext>
-            </a:extLst>
-          </p:cNvPr>
+          <p:cNvPr id="5" name="Image 0" descr="Five boxes left to right. Dec 10 2025, OMB/OPM memo: one Core HCM platform, agencies pause their own. Jun 10 2026, Core HCM award, Oracle Fusion Cloud HCM. Amber: onboarding months 1 to 5, the window; data standards, cleanup, interconnection design and the identity feed are decided. Red: interconnection go-live, the window closes; retrofitting identity means reopening it. FY 2028: one system, the government-wide adoption goal; EHRI and eOPF later made redundant.">    </p:cNvPr>
           <p:cNvPicPr>
             <a:picLocks noChangeAspect="1"/>
           </p:cNvPicPr>
@@ -21956,13 +21950,7 @@
       </p:sp>
       <p:pic>
         <p:nvPicPr>
-          <p:cNvPr id="5" name="Image 0" descr="">
-            <a:extLst>
-              <a:ext uri="{C183D7F6-B498-43B3-948B-1728B52AA6E4}">
-                <adec:decorative xmlns:adec="http://schemas.microsoft.com/office/drawing/2017/decorative" val="1"/>
-              </a:ext>
-            </a:extLst>
-          </p:cNvPr>
+          <p:cNvPr id="5" name="Image 0" descr="Left to right: Core HCM (extracts, ATOM feeds, REST, SCIM); boundary transformation (source-specific, replaceable); an amber middleware box with five duties: validate (fail closed), sequence, normalize to SCIM, write provenance, reconcile results; Graph /bulkUpload (Entra provisioning service), which writes to Active Directory (hybrid users, via the provisioning agent) and Entra ID (cloud-managed users). A dashed green line from the middleware goes to an evidence store (provenance and provisioning logs).">    </p:cNvPr>
           <p:cNvPicPr>
             <a:picLocks noChangeAspect="1"/>
           </p:cNvPicPr>

</xml_diff>